<commit_message>
Larger figure text, rewritten report prose, rebuilt slides
</commit_message>
<xml_diff>
--- a/Scientific Track/team/writeup/slides.pptx
+++ b/Scientific Track/team/writeup/slides.pptx
@@ -1790,12 +1790,12 @@
         </p:nvSpPr>
         <p:spPr>
           <a:xfrm>
-            <a:off x="7086600" y="1417320"/>
-            <a:ext cx="4663440" cy="2377440"/>
+            <a:off x="7086600" y="1737360"/>
+            <a:ext cx="4663440" cy="1783080"/>
           </a:xfrm>
           <a:prstGeom prst="roundRect">
             <a:avLst>
-              <a:gd name="adj" fmla="val 3846"/>
+              <a:gd name="adj" fmla="val 5128"/>
             </a:avLst>
           </a:prstGeom>
           <a:solidFill>
@@ -1825,8 +1825,8 @@
         </p:blipFill>
         <p:spPr>
           <a:xfrm>
-            <a:off x="7178040" y="1481328"/>
-            <a:ext cx="4480560" cy="2212848"/>
+            <a:off x="7178040" y="1810512"/>
+            <a:ext cx="4480560" cy="1600200"/>
           </a:xfrm>
           <a:prstGeom prst="rect">
             <a:avLst/>
@@ -1841,12 +1841,12 @@
         </p:nvSpPr>
         <p:spPr>
           <a:xfrm>
-            <a:off x="7086600" y="3931920"/>
-            <a:ext cx="4663440" cy="2377440"/>
+            <a:off x="7086600" y="3703320"/>
+            <a:ext cx="4663440" cy="1783080"/>
           </a:xfrm>
           <a:prstGeom prst="roundRect">
             <a:avLst>
-              <a:gd name="adj" fmla="val 3846"/>
+              <a:gd name="adj" fmla="val 5128"/>
             </a:avLst>
           </a:prstGeom>
           <a:solidFill>
@@ -1876,8 +1876,8 @@
         </p:blipFill>
         <p:spPr>
           <a:xfrm>
-            <a:off x="7178040" y="3995928"/>
-            <a:ext cx="4480560" cy="2212848"/>
+            <a:off x="7178040" y="3776472"/>
+            <a:ext cx="4480560" cy="1600200"/>
           </a:xfrm>
           <a:prstGeom prst="rect">
             <a:avLst/>
@@ -7654,8 +7654,8 @@
         </p:blipFill>
         <p:spPr>
           <a:xfrm>
-            <a:off x="8229600" y="4617720"/>
-            <a:ext cx="3520440" cy="1737360"/>
+            <a:off x="8229600" y="4663440"/>
+            <a:ext cx="3520440" cy="1252728"/>
           </a:xfrm>
           <a:prstGeom prst="rect">
             <a:avLst/>

</xml_diff>

<commit_message>
Update report and slides after review
</commit_message>
<xml_diff>
--- a/Scientific Track/team/writeup/slides.pptx
+++ b/Scientific Track/team/writeup/slides.pptx
@@ -862,7 +862,7 @@
           <a:p>
             <a:r>
               <a:rPr lang="en-US" dirty="0"/>
-              <a:t>At p = 0.01 the order drops to about 60 percent of its clean value, but not evenly: the ferromagnet falls to 0.37 while the antiphase keeps 0.59. With fixed thresholds the ferromagnet vanishes from the map. Wherever a threshold crossing survives, it moves to lower h. The field where the order changes fastest barely moves, median shift 0.005. At p = 0.05 the purity is only 20 percent above that of a fully mixed state. The noise does not change the Hamiltonian; what degrades is the prepared state. (60 s)</a:t>
+              <a:t>At p = 0.01 the order drops to about 60 percent of its clean value, but not evenly: the ferromagnet falls to 0.37 while the antiphase keeps 0.59. With fixed thresholds the ferromagnet vanishes from the map, though recalibrating the thresholds recovers it, so it is the absolute signal that is lost, not the phase. The field where the order changes fastest barely moves, median shift 0.005. At p = 0.05 the purity is only 20 percent above that of a fully mixed state. The noise does not change the Hamiltonian; what degrades is the prepared state. (60 s)</a:t>
             </a:r>
             <a:endParaRPr lang="en-US" dirty="0"/>
           </a:p>
@@ -950,7 +950,7 @@
           <a:p>
             <a:r>
               <a:rPr lang="en-US" dirty="0"/>
-              <a:t>We calculated the exact first-order effect of each of the 128 channels separately. The ferromagnet is about 2.3 times more sensitive than simple end-of-circuit counting would predict: errors made early are carried through the later gates, and early layers matter most. The first-order formula gets the direction of the shift right but underestimates its size, because p = 0.01 is already nonlinear for this circuit depth. This ranking belongs to this circuit and diagnostic; it is not a law about the phases. (45 s)</a:t>
+              <a:t>We calculated the exact first-order effect of each of the 128 channels separately. The ferromagnet is 2.3 times more sensitive than end-of-circuit counting predicts, the antiphase 1.6 times: errors made early are carried through the later gates. The states themselves do not explain the gap, since one flipped qubit costs both phases the same fraction of correlators; it is circuit dynamics and depth. The first-order formula gets the direction of the shift right but underestimates its size, because p = 0.01 is already nonlinear for this circuit depth. This ranking belongs to this circuit and diagnostic; it is not a law about the phases. (45 s)</a:t>
             </a:r>
             <a:endParaRPr lang="en-US" dirty="0"/>
           </a:p>
@@ -1126,7 +1126,7 @@
           <a:p>
             <a:r>
               <a:rPr lang="en-US" dirty="0"/>
-              <a:t>Zero-noise extrapolation on the correlators, never on the labels, with the clean result held out: at p = 0.01 the correlator error falls six-fold and 98 percent of labels are recovered, at the price of about 19 times more variance. At p = 0.05 it fails, because no signal is left to extrapolate. Parity verification helps only a little, because most errors keep the parity. (45 s)</a:t>
+              <a:t>Zero-noise extrapolation on the correlators, never on the labels, with the clean result held out: at p = 0.01 the correlator error falls six-fold and 98 percent of labels are recovered, at the price of about 19 times more variance. At p = 0.05 Richardson fails, because the correlators decay exponentially in p and a polynomial cannot follow that. A two-point exponential model does: 97.5 percent of labels come back, but at a variance cost of about fifty thousand, so on hardware this is not free. Parity verification helps only a little, because most errors keep the parity. (45 s)</a:t>
             </a:r>
             <a:endParaRPr lang="en-US" dirty="0"/>
           </a:p>
@@ -1214,7 +1214,7 @@
           <a:p>
             <a:r>
               <a:rPr lang="en-US" dirty="0"/>
-              <a:t>An accurate clean diagram; the ferro side converges quickly while the antiphase side drifts towards KT. For a circuit deep enough to be right, 1 percent noise already removes absolute order, and 5 percent leaves nothing: depth versus noise is the real trade-off. We also ran a quench from the fully polarised state: the Loschmidt rate peaks sharply only for quenches deep into the ordered side, but at p = 0.01 the channel error is about eight times the Trotter error, so the dynamical signature does not survive noise. Limitations: small N, approximate overlays, the fixed-parameter protocol, and no shot noise. (30 s)</a:t>
+              <a:t>An accurate clean diagram; the ferro side converges quickly while the antiphase side drifts towards KT. For a circuit deep enough to be right, 1 percent noise already removes absolute order, and 5 percent leaves only a weak signal: depth versus noise is the real trade-off. We also ran a quench from the fully polarised state: the Loschmidt rate peaks sharply only for quenches deep into the ordered side, but at p = 0.01 the channel error is about eight times the Trotter error, so the dynamical signature does not survive noise. Limitations: small N, approximate overlays, the fixed-parameter protocol, and no shot noise. (30 s)</a:t>
             </a:r>
             <a:endParaRPr lang="en-US" dirty="0"/>
           </a:p>
@@ -4660,7 +4660,7 @@
                 <a:ea typeface="Calibri" pitchFamily="34" charset="-122"/>
                 <a:cs typeface="Calibri" pitchFamily="34" charset="-120"/>
               </a:rPr>
-              <a:t>of ferro points keep their label at p = 0.01 (antiphase 46%, para 89%)</a:t>
+              <a:t>of ferro points keep their label at p = 0.01 under fixed thresholds; recalibrated thresholds recover all 142</a:t>
             </a:r>
             <a:endParaRPr lang="en-US" sz="1200" dirty="0"/>
           </a:p>
@@ -4870,7 +4870,7 @@
                 <a:ea typeface="Calibri" pitchFamily="34" charset="-122"/>
                 <a:cs typeface="Calibri" pitchFamily="34" charset="-120"/>
               </a:rPr>
-              <a:t>purity at p = 0.05, vs 0.0039 for the maximally mixed state</a:t>
+              <a:t>purity at p = 0.05 (maximally mixed: 0.0039); order parameters keep 8.5%, m_x 16%</a:t>
             </a:r>
             <a:endParaRPr lang="en-US" sz="1200" dirty="0"/>
           </a:p>
@@ -5319,7 +5319,7 @@
               <a:buNone/>
             </a:pPr>
             <a:r>
-              <a:rPr lang="en-US" sz="3400" b="1" dirty="0">
+              <a:rPr lang="en-US" sz="2800" b="1" dirty="0">
                 <a:solidFill>
                   <a:srgbClr val="2E9E5B"/>
                 </a:solidFill>
@@ -5327,9 +5327,9 @@
                 <a:ea typeface="Cambria" pitchFamily="34" charset="-122"/>
                 <a:cs typeface="Cambria" pitchFamily="34" charset="-120"/>
               </a:rPr>
-              <a:t>−48</a:t>
-            </a:r>
-            <a:endParaRPr lang="en-US" sz="3400" dirty="0"/>
+              <a:t>−32 to −48</a:t>
+            </a:r>
+            <a:endParaRPr lang="en-US" sz="2800" dirty="0"/>
           </a:p>
         </p:txBody>
       </p:sp>
@@ -5424,7 +5424,7 @@
               <a:buNone/>
             </a:pPr>
             <a:r>
-              <a:rPr lang="en-US" sz="3400" b="1" dirty="0">
+              <a:rPr lang="en-US" sz="2600" b="1" dirty="0">
                 <a:solidFill>
                   <a:srgbClr val="9AA3AF"/>
                 </a:solidFill>
@@ -5432,9 +5432,9 @@
                 <a:ea typeface="Cambria" pitchFamily="34" charset="-122"/>
                 <a:cs typeface="Cambria" pitchFamily="34" charset="-120"/>
               </a:rPr>
-              <a:t>−43</a:t>
-            </a:r>
-            <a:endParaRPr lang="en-US" sz="3400" dirty="0"/>
+              <a:t>−43 | −21</a:t>
+            </a:r>
+            <a:endParaRPr lang="en-US" sz="2600" dirty="0"/>
           </a:p>
         </p:txBody>
       </p:sp>
@@ -5471,7 +5471,7 @@
                 <a:ea typeface="Calibri" pitchFamily="34" charset="-122"/>
                 <a:cs typeface="Calibri" pitchFamily="34" charset="-120"/>
               </a:rPr>
-              <a:t>if every hit acted as end-of-circuit noise</a:t>
+              <a:t>end-of-circuit baseline: pair correlators | m_x</a:t>
             </a:r>
             <a:endParaRPr lang="en-US" sz="1200" dirty="0"/>
           </a:p>
@@ -5514,7 +5514,7 @@
                 <a:ea typeface="Calibri" pitchFamily="34" charset="-122"/>
                 <a:cs typeface="Calibri" pitchFamily="34" charset="-120"/>
               </a:rPr>
-              <a:t>Mid-circuit errors are carried through later CNOT–RZ–CNOT gadgets, so they damage ZZ order about 2.3× more than terminal noise would.</a:t>
+              <a:t>Measured sensitivities exceed their end-of-circuit baselines by 2.3× (ferro), 1.6× (antiphase) and 1.5–2.3× (m_x): mid-circuit errors propagate through later CNOT–RZ–CNOT gadgets.</a:t>
             </a:r>
             <a:endParaRPr lang="en-US" sz="1300" dirty="0"/>
           </a:p>
@@ -5556,7 +5556,7 @@
                 <a:ea typeface="Calibri" pitchFamily="34" charset="-122"/>
                 <a:cs typeface="Calibri" pitchFamily="34" charset="-120"/>
               </a:rPr>
-              <a:t>The GHZ-like ferro ring loses all N(N−1) positive correlators to a single propagated X/Y error; O_A mixes signs, so damage partly cancels.</a:t>
+              <a:t>The states themselves are not the reason: one flipped qubit removes the same fraction (about 4/N) of the correlators in O_F and O_A. The gap is circuit dynamics plus the ferro state needing full depth.</a:t>
             </a:r>
             <a:endParaRPr lang="en-US" sz="1300" dirty="0"/>
           </a:p>
@@ -6304,8 +6304,8 @@
         </p:blipFill>
         <p:spPr>
           <a:xfrm>
-            <a:off x="457200" y="1188720"/>
-            <a:ext cx="11274552" cy="3374136"/>
+            <a:off x="457200" y="1371600"/>
+            <a:ext cx="11274552" cy="2743200"/>
           </a:xfrm>
           <a:prstGeom prst="rect">
             <a:avLst/>
@@ -6345,7 +6345,7 @@
                 <a:ea typeface="Calibri" pitchFamily="34" charset="-122"/>
                 <a:cs typeface="Calibri" pitchFamily="34" charset="-120"/>
               </a:rPr>
-              <a:t>Fixed thresholds. Raw p = 0.05; ZNE at p = 0.05 (fails); parity-verified p = 0.05; ZNE at p = 0.01 (Richardson, λ = 1, 2, 3, p = 0 truth held out).</a:t>
+              <a:t>Fixed thresholds. Raw p = 0.05; Richardson ZNE at p = 0.05 (fails); parity-verified p = 0.05; Richardson ZNE at p = 0.01; two-point exponential ZNE at p = 0.05 (λ = 1, 2).</a:t>
             </a:r>
             <a:endParaRPr lang="en-US" sz="1050" dirty="0"/>
           </a:p>
@@ -6613,7 +6613,7 @@
               <a:buNone/>
             </a:pPr>
             <a:r>
-              <a:rPr lang="en-US" sz="3400" b="1" dirty="0">
+              <a:rPr lang="en-US" sz="2800" b="1" dirty="0">
                 <a:solidFill>
                   <a:srgbClr val="E07A2F"/>
                 </a:solidFill>
@@ -6621,9 +6621,9 @@
                 <a:ea typeface="Cambria" pitchFamily="34" charset="-122"/>
                 <a:cs typeface="Cambria" pitchFamily="34" charset="-120"/>
               </a:rPr>
-              <a:t>× 19</a:t>
-            </a:r>
-            <a:endParaRPr lang="en-US" sz="3400" dirty="0"/>
+              <a:t>97.5%</a:t>
+            </a:r>
+            <a:endParaRPr lang="en-US" sz="2800" dirty="0"/>
           </a:p>
         </p:txBody>
       </p:sp>
@@ -6660,7 +6660,7 @@
                 <a:ea typeface="Calibri" pitchFamily="34" charset="-122"/>
                 <a:cs typeface="Calibri" pitchFamily="34" charset="-120"/>
               </a:rPr>
-              <a:t>variance amplification Σγ²; at p = 0.05 ZNE fails (signal ≈ 1%)</a:t>
+              <a:t>labels recovered at p = 0.05 by exponential ZNE (Richardson: fails); variance cost ≈ 5 × 10⁴</a:t>
             </a:r>
             <a:endParaRPr lang="en-US" sz="1200" dirty="0"/>
           </a:p>
@@ -6718,7 +6718,7 @@
               <a:buNone/>
             </a:pPr>
             <a:r>
-              <a:rPr lang="en-US" sz="3400" b="1" dirty="0">
+              <a:rPr lang="en-US" sz="2600" b="1" dirty="0">
                 <a:solidFill>
                   <a:srgbClr val="9AA3AF"/>
                 </a:solidFill>
@@ -6726,9 +6726,9 @@
                 <a:ea typeface="Cambria" pitchFamily="34" charset="-122"/>
                 <a:cs typeface="Cambria" pitchFamily="34" charset="-120"/>
               </a:rPr>
-              <a:t>71%</a:t>
-            </a:r>
-            <a:endParaRPr lang="en-US" sz="3400" dirty="0"/>
+              <a:t>× 19 · 71%</a:t>
+            </a:r>
+            <a:endParaRPr lang="en-US" sz="2600" dirty="0"/>
           </a:p>
         </p:txBody>
       </p:sp>
@@ -6765,7 +6765,7 @@
                 <a:ea typeface="Calibri" pitchFamily="34" charset="-122"/>
                 <a:cs typeface="Calibri" pitchFamily="34" charset="-120"/>
               </a:rPr>
-              <a:t>parity-verification acceptance at p = 0.01; error only 0.063 → 0.053</a:t>
+              <a:t>Richardson variance factor at p = 0.01 · parity-check acceptance (error only 0.063 → 0.053)</a:t>
             </a:r>
             <a:endParaRPr lang="en-US" sz="1200" dirty="0"/>
           </a:p>
@@ -7134,7 +7134,7 @@
                 <a:ea typeface="Calibri" pitchFamily="34" charset="-122"/>
                 <a:cs typeface="Calibri" pitchFamily="34" charset="-120"/>
               </a:rPr>
-              <a:t>1% noise removes the ferromagnet: </a:t>
+              <a:t>1% noise removes absolute ferromagnetic order: </a:t>
             </a:r>
             <a:pPr indent="0" marL="0">
               <a:buNone/>
@@ -7148,7 +7148,7 @@
                 <a:ea typeface="Calibri" pitchFamily="34" charset="-122"/>
                 <a:cs typeface="Calibri" pitchFamily="34" charset="-120"/>
               </a:rPr>
-              <a:t>under fixed thresholds, while derivative-defined boundaries stay put; 5% leaves no usable signal.</a:t>
+              <a:t>under fixed thresholds, while derivative-defined boundaries stay put; recalibrated thresholds still find the phase. 5% leaves only a weak signal.</a:t>
             </a:r>
             <a:endParaRPr lang="en-US" sz="1450" dirty="0"/>
           </a:p>
@@ -7368,7 +7368,7 @@
                 <a:ea typeface="Calibri" pitchFamily="34" charset="-122"/>
                 <a:cs typeface="Calibri" pitchFamily="34" charset="-120"/>
               </a:rPr>
-              <a:t>ZNE turns p = 0.01 back into a correct diagram: </a:t>
+              <a:t>Mitigation depends on the model: </a:t>
             </a:r>
             <a:pPr indent="0" marL="0">
               <a:buNone/>
@@ -7382,7 +7382,7 @@
                 <a:ea typeface="Calibri" pitchFamily="34" charset="-122"/>
                 <a:cs typeface="Calibri" pitchFamily="34" charset="-120"/>
               </a:rPr>
-              <a:t>parity checks help little; noise-aware re-optimisation buys energy, not diagnostics.</a:t>
+              <a:t>Richardson ZNE restores p = 0.01; only an exponential model restores p = 0.05, at ~5 × 10⁴ variance cost. Parity checks help little.</a:t>
             </a:r>
             <a:endParaRPr lang="en-US" sz="1450" dirty="0"/>
           </a:p>

</xml_diff>